<commit_message>
Simplify 6th-10th place labels and update group relay description
</commit_message>
<xml_diff>
--- a/prizes_presentation.pptx
+++ b/prizes_presentation.pptx
@@ -4053,7 +4053,7 @@
                         </a:defRPr>
                       </a:pPr>
                       <a:r>
-                        <a:t>6th - 10th (each)</a:t>
+                        <a:t>6th-10th (each)</a:t>
                       </a:r>
                     </a:p>
                   </a:txBody>
@@ -5218,7 +5218,7 @@
                         </a:defRPr>
                       </a:pPr>
                       <a:r>
-                        <a:t>6th - 10th</a:t>
+                        <a:t>6th-10th</a:t>
                       </a:r>
                     </a:p>
                   </a:txBody>

</xml_diff>

<commit_message>
Align Open and Veteran prize structures and update budget metrics
</commit_message>
<xml_diff>
--- a/prizes_presentation.pptx
+++ b/prizes_presentation.pptx
@@ -3424,7 +3424,7 @@
               </a:defRPr>
             </a:pPr>
             <a:r>
-              <a:t>•  1st Place Veteran: RM 1,500</a:t>
+              <a:t>•  1st Place Veteran: RM 2,000 (Same as Open)</a:t>
             </a:r>
           </a:p>
           <a:p>
@@ -3752,7 +3752,7 @@
               </a:defRPr>
             </a:pPr>
             <a:r>
-              <a:t>•  1st Place Veteran: RM 800</a:t>
+              <a:t>•  1st Place Veteran: RM 1,000 (Same as Open)</a:t>
             </a:r>
           </a:p>
           <a:p>
@@ -4273,7 +4273,7 @@
                         </a:defRPr>
                       </a:pPr>
                       <a:r>
-                        <a:t>RM 1,500</a:t>
+                        <a:t>RM 2,000</a:t>
                       </a:r>
                     </a:p>
                   </a:txBody>
@@ -4297,7 +4297,7 @@
                         </a:defRPr>
                       </a:pPr>
                       <a:r>
-                        <a:t>RM 900</a:t>
+                        <a:t>RM 1,200</a:t>
                       </a:r>
                     </a:p>
                   </a:txBody>
@@ -4321,7 +4321,7 @@
                         </a:defRPr>
                       </a:pPr>
                       <a:r>
-                        <a:t>RM 600</a:t>
+                        <a:t>RM 800</a:t>
                       </a:r>
                     </a:p>
                   </a:txBody>
@@ -4345,7 +4345,7 @@
                         </a:defRPr>
                       </a:pPr>
                       <a:r>
-                        <a:t>RM 400</a:t>
+                        <a:t>RM 500</a:t>
                       </a:r>
                     </a:p>
                   </a:txBody>
@@ -4369,7 +4369,7 @@
                         </a:defRPr>
                       </a:pPr>
                       <a:r>
-                        <a:t>RM 250</a:t>
+                        <a:t>RM 300</a:t>
                       </a:r>
                     </a:p>
                   </a:txBody>
@@ -4393,7 +4393,7 @@
                         </a:defRPr>
                       </a:pPr>
                       <a:r>
-                        <a:t>RM 120</a:t>
+                        <a:t>RM 150</a:t>
                       </a:r>
                     </a:p>
                   </a:txBody>
@@ -4783,7 +4783,7 @@
                         </a:defRPr>
                       </a:pPr>
                       <a:r>
-                        <a:t>RM 800</a:t>
+                        <a:t>RM 1,000</a:t>
                       </a:r>
                     </a:p>
                   </a:txBody>
@@ -4807,7 +4807,7 @@
                         </a:defRPr>
                       </a:pPr>
                       <a:r>
-                        <a:t>RM 500</a:t>
+                        <a:t>RM 600</a:t>
                       </a:r>
                     </a:p>
                   </a:txBody>
@@ -4831,7 +4831,7 @@
                         </a:defRPr>
                       </a:pPr>
                       <a:r>
-                        <a:t>RM 300</a:t>
+                        <a:t>RM 400</a:t>
                       </a:r>
                     </a:p>
                   </a:txBody>
@@ -4855,7 +4855,7 @@
                         </a:defRPr>
                       </a:pPr>
                       <a:r>
-                        <a:t>RM 200</a:t>
+                        <a:t>RM 250</a:t>
                       </a:r>
                     </a:p>
                   </a:txBody>
@@ -4879,7 +4879,7 @@
                         </a:defRPr>
                       </a:pPr>
                       <a:r>
-                        <a:t>RM 120</a:t>
+                        <a:t>RM 150</a:t>
                       </a:r>
                     </a:p>
                   </a:txBody>
@@ -4903,7 +4903,7 @@
                         </a:defRPr>
                       </a:pPr>
                       <a:r>
-                        <a:t>RM 60</a:t>
+                        <a:t>RM 80</a:t>
                       </a:r>
                     </a:p>
                   </a:txBody>
@@ -4949,7 +4949,7 @@
               </a:defRPr>
             </a:pPr>
             <a:r>
-              <a:t>Total Cash Prize Budget Required (Option A): RM 31,640</a:t>
+              <a:t>Total Cash Prize Budget Required (Option A): RM 35,400</a:t>
             </a:r>
           </a:p>
         </p:txBody>
@@ -5438,7 +5438,7 @@
                         </a:defRPr>
                       </a:pPr>
                       <a:r>
-                        <a:t>RM 1,500</a:t>
+                        <a:t>RM 2,000</a:t>
                       </a:r>
                     </a:p>
                   </a:txBody>
@@ -5462,7 +5462,7 @@
                         </a:defRPr>
                       </a:pPr>
                       <a:r>
-                        <a:t>RM 900</a:t>
+                        <a:t>RM 1,200</a:t>
                       </a:r>
                     </a:p>
                   </a:txBody>
@@ -5486,7 +5486,7 @@
                         </a:defRPr>
                       </a:pPr>
                       <a:r>
-                        <a:t>RM 600</a:t>
+                        <a:t>RM 800</a:t>
                       </a:r>
                     </a:p>
                   </a:txBody>
@@ -5510,7 +5510,7 @@
                         </a:defRPr>
                       </a:pPr>
                       <a:r>
-                        <a:t>RM 400</a:t>
+                        <a:t>RM 500</a:t>
                       </a:r>
                     </a:p>
                   </a:txBody>
@@ -5534,7 +5534,7 @@
                         </a:defRPr>
                       </a:pPr>
                       <a:r>
-                        <a:t>RM 250</a:t>
+                        <a:t>RM 300</a:t>
                       </a:r>
                     </a:p>
                   </a:txBody>
@@ -5948,7 +5948,7 @@
                         </a:defRPr>
                       </a:pPr>
                       <a:r>
-                        <a:t>RM 800</a:t>
+                        <a:t>RM 1,000</a:t>
                       </a:r>
                     </a:p>
                   </a:txBody>
@@ -5972,7 +5972,7 @@
                         </a:defRPr>
                       </a:pPr>
                       <a:r>
-                        <a:t>RM 500</a:t>
+                        <a:t>RM 600</a:t>
                       </a:r>
                     </a:p>
                   </a:txBody>
@@ -5996,7 +5996,7 @@
                         </a:defRPr>
                       </a:pPr>
                       <a:r>
-                        <a:t>RM 300</a:t>
+                        <a:t>RM 400</a:t>
                       </a:r>
                     </a:p>
                   </a:txBody>
@@ -6020,7 +6020,7 @@
                         </a:defRPr>
                       </a:pPr>
                       <a:r>
-                        <a:t>RM 200</a:t>
+                        <a:t>RM 250</a:t>
                       </a:r>
                     </a:p>
                   </a:txBody>
@@ -6044,7 +6044,7 @@
                         </a:defRPr>
                       </a:pPr>
                       <a:r>
-                        <a:t>RM 120</a:t>
+                        <a:t>RM 150</a:t>
                       </a:r>
                     </a:p>
                   </a:txBody>
@@ -6114,7 +6114,7 @@
               </a:defRPr>
             </a:pPr>
             <a:r>
-              <a:t>Total Cash Prize Budget Required (Option B): RM 25,440</a:t>
+              <a:t>Total Cash Prize Budget Required (Option B): RM 30,800</a:t>
             </a:r>
           </a:p>
         </p:txBody>
@@ -6289,7 +6289,7 @@
               </a:defRPr>
             </a:pPr>
             <a:r>
-              <a:t>Total Budget: RM 31,640</a:t>
+              <a:t>Total Budget: RM 35,400</a:t>
             </a:r>
           </a:p>
           <a:p>
@@ -6406,7 +6406,7 @@
               </a:defRPr>
             </a:pPr>
             <a:r>
-              <a:t>Total Budget: RM 25,440</a:t>
+              <a:t>Total Budget: RM 30,800</a:t>
             </a:r>
           </a:p>
           <a:p>
@@ -6422,7 +6422,7 @@
               </a:defRPr>
             </a:pPr>
             <a:r>
-              <a:t>• Saves RM 6,200 (19.6% reduction in total prize pool).</a:t>
+              <a:t>• Saves RM 4,600 (13.0% reduction in total prize pool).</a:t>
             </a:r>
             <a:br/>
             <a:r>
@@ -6526,7 +6526,7 @@
               </a:defRPr>
             </a:pPr>
             <a:r>
-              <a:t>For an event targeting 8,000 participants, Option A is highly recommended. The additional RM 6,200 required to pay cash down to 10th place is easily offset by the incremental ticket revenue from competitive running clubs. By advertising cash prizes up to 10th place, you establish the event as a premier competitive milestone on the national calendar.</a:t>
+              <a:t>For an event targeting 8,000 participants, Option A is highly recommended. The additional RM 4,600 required to pay cash down to 10th place is easily offset by the incremental ticket revenue from competitive running clubs. By advertising cash prizes up to 10th place, you establish the event as a premier competitive milestone on the national calendar.</a:t>
             </a:r>
           </a:p>
         </p:txBody>

</xml_diff>